<commit_message>
chore(repo): complete master cleanup, test reconciliation (15/15), name standardization, and team contribution audit
</commit_message>
<xml_diff>
--- a/deliverables/VISIONARY_TH71108_FINAL_PRESENTATION.pptx
+++ b/deliverables/VISIONARY_TH71108_FINAL_PRESENTATION.pptx
@@ -522,7 +522,7 @@
           </a:p>
           <a:p>
             <a:r>
-              <a:t>Kính chào Thầy và các bạn trong hội đồng! Em tên là Quách Khoa Đức, đại diện nhóm VISIONARY API bảo vệ đồ án tốt nghiệp môn Web API. Hệ thống của nhóm gồm một Web API trung tâm trên ASP.NET Core 8 và ba ứng dụng khách: Web Next.js, Desktop Windows Forms và Mobile Android. Bốn thành viên tham gia trình bày theo đúng thứ tự: Em Quách Khoa Đức phụ trách mở đầu, kiến trúc và Web Client; bạn Đào Trí Khang phụ trách Android; bạn Hồ Đoàng Nguyên Khang phụ trách Web API, Swagger và Database; và bạn Võ Ngọc Minh Đạt phụ trách Windows Forms cùng phân tích sự cố và kết luận.</a:t>
+              <a:t>Kính chào Thầy và các bạn trong hội đồng! Em tên là Quách Khoa Đức, đại diện nhóm VISIONARY API bảo vệ đồ án tốt nghiệp môn Web API. Hệ thống của nhóm gồm một Web API trung tâm trên ASP.NET Core 8 và ba ứng dụng khách: Web Next.js, Desktop Windows Forms và Mobile Android. Bốn thành viên tham gia trình bày theo đúng thứ tự: Em Quách Khoa Đức phụ trách mở đầu, kiến trúc và Web Client; bạn Đào Trí Khang phụ trách Android; bạn Hồ Đoàn Nguyên Khang phụ trách Web API, Swagger và Database; và bạn Võ Ngọc Minh Đạt phụ trách Windows Forms cùng phân tích sự cố và kết luận.</a:t>
             </a:r>
           </a:p>
         </p:txBody>
@@ -592,7 +592,7 @@
           <a:lstStyle/>
           <a:p>
             <a:r>
-              <a:t>LỜI THUYẾT TRÌNH (HỒ ĐOÀNG NGUYÊN KHANG - 1p05s):</a:t>
+              <a:t>LỜI THUYẾT TRÌNH (HỒ ĐOÀN NGUYÊN KHANG - 1p05s):</a:t>
             </a:r>
           </a:p>
           <a:p>
@@ -667,7 +667,7 @@
           <a:lstStyle/>
           <a:p>
             <a:r>
-              <a:t>LỜI THUYẾT TRÌNH (HỒ ĐOÀNG NGUYÊN KHANG - 1p00s):</a:t>
+              <a:t>LỜI THUYẾT TRÌNH (HỒ ĐOÀN NGUYÊN KHANG - 1p00s):</a:t>
             </a:r>
           </a:p>
           <a:p>
@@ -1512,7 +1512,7 @@
           </a:p>
           <a:p>
             <a:r>
-              <a:t>Sau đây, em xin phép demo trực tiếp ứng dụng Android đang chạy trên máy ảo. [KHANG THAO TÁC]: Em mở app, danh sách sự kiện được tải về mượt mà qua API GET /api/events. Em chọn sự kiện 'Hội thảo Kỹ năng Hội nhập Quốc tế' và bấm nút Đăng ký tham gia. Ứng dụng gửi request POST lên Web API kèm mã Bearer token của sinh viên. Server xác nhận thành công và hiển thị thông báo đã đăng ký. Dữ liệu này đã lập tức được lưu vào cơ sở dữ liệu chung và sẽ được anh Đạt kiểm tra ngay trên WinForms ở phần sau. Sau đây, em xin chuyển lời sang bạn Hồ Đoàng Nguyên Khang để phân tích về Web API và Swagger.</a:t>
+              <a:t>Sau đây, em xin phép demo trực tiếp ứng dụng Android đang chạy trên máy ảo. [KHANG THAO TÁC]: Em mở app, danh sách sự kiện được tải về mượt mà qua API GET /api/events. Em chọn sự kiện 'Hội thảo Kỹ năng Hội nhập Quốc tế' và bấm nút Đăng ký tham gia. Ứng dụng gửi request POST lên Web API kèm mã Bearer token của sinh viên. Server xác nhận thành công và hiển thị thông báo đã đăng ký. Dữ liệu này đã lập tức được lưu vào cơ sở dữ liệu chung và sẽ được anh Đạt kiểm tra ngay trên WinForms ở phần sau. Sau đây, em xin chuyển lời sang bạn Hồ Đoàn Nguyên Khang để phân tích về Web API và Swagger.</a:t>
             </a:r>
           </a:p>
         </p:txBody>
@@ -1582,12 +1582,12 @@
           <a:lstStyle/>
           <a:p>
             <a:r>
-              <a:t>LỜI THUYẾT TRÌNH (HỒ ĐOÀNG NGUYÊN KHANG - 1'00"):</a:t>
-            </a:r>
-          </a:p>
-          <a:p>
-            <a:r>
-              <a:t>Kính chào Thầy và các bạn! Em tên là Hồ Đoàng Nguyên Khang, phụ trách ASP.NET Core Web API, tài liệu Swagger và Cơ sở dữ liệu. Bên trái là ảnh chụp Swagger UI thực tế của hệ thống tại địa chỉ visionary-api-gb51.onrender.com/swagger. Bảng bên phải là hợp đồng API thực tế mà nhóm đã triển khai và tiêu thụ. Các endpoint được phân định quyền rõ ràng: GET /api/events mở công khai; POST /api/events/{id}/register cần đăng nhập; và POST /api/events tạo sự kiện bắt buộc quyền Admin hoặc Ban Chủ Nhiệm. Toàn bộ tên trường JSON đều dùng camelCase, đảm bảo tính nhất quán trên cả ba nền tảng.</a:t>
+              <a:t>LỜI THUYẾT TRÌNH (HỒ ĐOÀN NGUYÊN KHANG - 1'00"):</a:t>
+            </a:r>
+          </a:p>
+          <a:p>
+            <a:r>
+              <a:t>Kính chào Thầy và các bạn! Em tên là Hồ Đoàn Nguyên Khang, phụ trách ASP.NET Core Web API, tài liệu Swagger và Cơ sở dữ liệu. Bên trái là ảnh chụp Swagger UI thực tế của hệ thống tại địa chỉ visionary-api-gb51.onrender.com/swagger. Bảng bên phải là hợp đồng API thực tế mà nhóm đã triển khai và tiêu thụ. Các endpoint được phân định quyền rõ ràng: GET /api/events mở công khai; POST /api/events/{id}/register cần đăng nhập; và POST /api/events tạo sự kiện bắt buộc quyền Admin hoặc Ban Chủ Nhiệm. Toàn bộ tên trường JSON đều dùng camelCase, đảm bảo tính nhất quán trên cả ba nền tảng.</a:t>
             </a:r>
           </a:p>
         </p:txBody>
@@ -1657,7 +1657,7 @@
           <a:lstStyle/>
           <a:p>
             <a:r>
-              <a:t>LỜI THUYẾT TRÌNH (HỒ ĐOÀNG NGUYÊN KHANG - 1p00s):</a:t>
+              <a:t>LỜI THUYẾT TRÌNH (HỒ ĐOÀN NGUYÊN KHANG - 1p00s):</a:t>
             </a:r>
           </a:p>
           <a:p>
@@ -5236,7 +5236,7 @@
               </a:defRPr>
             </a:pPr>
             <a:r>
-              <a:t>3. Hồ Đoàng Nguyên Khang</a:t>
+              <a:t>3. Hồ Đoàn Nguyên Khang</a:t>
             </a:r>
           </a:p>
           <a:p>
@@ -5858,7 +5858,7 @@
               </a:defRPr>
             </a:pPr>
             <a:r>
-              <a:t>VISIONARY API – TH71108 Web API (DNTU) | Người trình bày: Hồ Đoàng Nguyên Khang | Slide 10/16</a:t>
+              <a:t>VISIONARY API – TH71108 Web API (DNTU) | Người trình bày: Hồ Đoàn Nguyên Khang | Slide 10/16</a:t>
             </a:r>
           </a:p>
         </p:txBody>
@@ -6985,7 +6985,7 @@
               </a:defRPr>
             </a:pPr>
             <a:r>
-              <a:t>VISIONARY API – TH71108 Web API (DNTU) | Người trình bày: Hồ Đoàng Nguyên Khang | Slide 11/16</a:t>
+              <a:t>VISIONARY API – TH71108 Web API (DNTU) | Người trình bày: Hồ Đoàn Nguyên Khang | Slide 11/16</a:t>
             </a:r>
           </a:p>
         </p:txBody>
@@ -18134,7 +18134,7 @@
               </a:defRPr>
             </a:pPr>
             <a:r>
-              <a:t>VISIONARY API – TH71108 Web API (DNTU) | Người trình bày: Hồ Đoàng Nguyên Khang | Slide 8/16</a:t>
+              <a:t>VISIONARY API – TH71108 Web API (DNTU) | Người trình bày: Hồ Đoàn Nguyên Khang | Slide 8/16</a:t>
             </a:r>
           </a:p>
         </p:txBody>
@@ -19296,7 +19296,7 @@
               </a:defRPr>
             </a:pPr>
             <a:r>
-              <a:t>VISIONARY API – TH71108 Web API (DNTU) | Người trình bày: Hồ Đoàng Nguyên Khang | Slide 9/16</a:t>
+              <a:t>VISIONARY API – TH71108 Web API (DNTU) | Người trình bày: Hồ Đoàn Nguyên Khang | Slide 9/16</a:t>
             </a:r>
           </a:p>
         </p:txBody>

</xml_diff>